<commit_message>
Redesign Methodology slide into polished 3-pillar card layout matching visual specification
</commit_message>
<xml_diff>
--- a/reports/mid_sem_presentation.pptx
+++ b/reports/mid_sem_presentation.pptx
@@ -7554,7 +7554,7 @@
               </a:defRPr>
             </a:pPr>
             <a:r>
-              <a:t>TECHNICAL METHODOLOGY</a:t>
+              <a:t>TECHNICAL METHODOLOGY &amp; MATHEMATICAL FORMULATIONS</a:t>
             </a:r>
           </a:p>
         </p:txBody>
@@ -7589,7 +7589,7 @@
               </a:defRPr>
             </a:pPr>
             <a:r>
-              <a:t>Methodology: Clinical Preprocessing &amp; Mathematical Formulations</a:t>
+              <a:t>Methodology: Formulations &amp; Optimization</a:t>
             </a:r>
           </a:p>
         </p:txBody>
@@ -7638,7 +7638,7 @@
         <p:spPr>
           <a:xfrm>
             <a:off x="731520" y="1280160"/>
-            <a:ext cx="3410712" cy="2286000"/>
+            <a:ext cx="3337560" cy="4937760"/>
           </a:xfrm>
           <a:prstGeom prst="roundRect">
             <a:avLst/>
@@ -7648,7 +7648,7 @@
           </a:solidFill>
           <a:ln w="12700">
             <a:solidFill>
-              <a:srgbClr val="E2E8F0"/>
+              <a:srgbClr val="DBEAFE"/>
             </a:solidFill>
           </a:ln>
         </p:spPr>
@@ -7682,8 +7682,43 @@
         </p:nvSpPr>
         <p:spPr>
           <a:xfrm>
-            <a:off x="868680" y="1417319"/>
-            <a:ext cx="3136392" cy="2011680"/>
+            <a:off x="914400" y="1371600"/>
+            <a:ext cx="2971800" cy="457200"/>
+          </a:xfrm>
+          <a:prstGeom prst="rect">
+            <a:avLst/>
+          </a:prstGeom>
+          <a:noFill/>
+        </p:spPr>
+        <p:txBody>
+          <a:bodyPr wrap="none">
+            <a:spAutoFit/>
+          </a:bodyPr>
+          <a:lstStyle/>
+          <a:p>
+            <a:pPr>
+              <a:defRPr sz="1700" b="1">
+                <a:solidFill>
+                  <a:srgbClr val="1E3A8A"/>
+                </a:solidFill>
+              </a:defRPr>
+            </a:pPr>
+            <a:r>
+              <a:t>❶  Preprocessing</a:t>
+            </a:r>
+          </a:p>
+        </p:txBody>
+      </p:sp>
+      <p:sp>
+        <p:nvSpPr>
+          <p:cNvPr id="8" name="TextBox 7"/>
+          <p:cNvSpPr txBox="1"/>
+          <p:nvPr/>
+        </p:nvSpPr>
+        <p:spPr>
+          <a:xfrm>
+            <a:off x="914400" y="1920240"/>
+            <a:ext cx="2971800" cy="4114800"/>
           </a:xfrm>
           <a:prstGeom prst="rect">
             <a:avLst/>
@@ -7697,51 +7732,103 @@
           <a:lstStyle/>
           <a:p>
             <a:pPr>
-              <a:defRPr sz="1200" b="1">
+              <a:defRPr sz="1300" b="1">
                 <a:solidFill>
                   <a:srgbClr val="1E3A8A"/>
                 </a:solidFill>
               </a:defRPr>
             </a:pPr>
             <a:r>
-              <a:t>1. Clinical Preprocessing</a:t>
+              <a:t>Ben Graham Circular Crop</a:t>
             </a:r>
           </a:p>
           <a:p>
             <a:pPr>
               <a:spcBef>
-                <a:spcPts val="600"/>
+                <a:spcPts val="300"/>
               </a:spcBef>
-              <a:defRPr sz="1000">
-                <a:solidFill>
-                  <a:srgbClr val="0F172A"/>
-                </a:solidFill>
-              </a:defRPr>
-            </a:pPr>
-            <a:r>
-              <a:t>• Ben Graham Circular Crop: Automates contour thresholding, circular masking, and black margin removal.</a:t>
-            </a:r>
-            <a:br/>
-            <a:r>
-              <a:t>• Green-Channel CLAHE: Isolates 540-575nm spectrum where hemoglobin absorbs light, maximizing lesion contrast.</a:t>
-            </a:r>
-            <a:br/>
-            <a:r>
-              <a:t>• Bilinear Resize: Standardizes images to 224x224x3.</a:t>
-            </a:r>
-          </a:p>
-        </p:txBody>
-      </p:sp>
-      <p:sp>
-        <p:nvSpPr>
-          <p:cNvPr id="8" name="Rounded Rectangle 7"/>
+              <a:defRPr sz="1100">
+                <a:solidFill>
+                  <a:srgbClr val="475569"/>
+                </a:solidFill>
+              </a:defRPr>
+            </a:pPr>
+            <a:r>
+              <a:t>Masks non-retinal borders and centers the image; removes dark margins and optical artifacts.</a:t>
+            </a:r>
+          </a:p>
+          <a:p>
+            <a:pPr>
+              <a:spcBef>
+                <a:spcPts val="1400"/>
+              </a:spcBef>
+              <a:defRPr sz="1300" b="1">
+                <a:solidFill>
+                  <a:srgbClr val="1E3A8A"/>
+                </a:solidFill>
+              </a:defRPr>
+            </a:pPr>
+            <a:r>
+              <a:t>Green-Channel CLAHE</a:t>
+            </a:r>
+          </a:p>
+          <a:p>
+            <a:pPr>
+              <a:spcBef>
+                <a:spcPts val="300"/>
+              </a:spcBef>
+              <a:defRPr sz="1100">
+                <a:solidFill>
+                  <a:srgbClr val="475569"/>
+                </a:solidFill>
+              </a:defRPr>
+            </a:pPr>
+            <a:r>
+              <a:t>Maximizes lesion contrast in the 540–575 nm spectrum where hemoglobin absorbs light.</a:t>
+            </a:r>
+          </a:p>
+          <a:p>
+            <a:pPr>
+              <a:spcBef>
+                <a:spcPts val="1400"/>
+              </a:spcBef>
+              <a:defRPr sz="1300" b="1">
+                <a:solidFill>
+                  <a:srgbClr val="1E3A8A"/>
+                </a:solidFill>
+              </a:defRPr>
+            </a:pPr>
+            <a:r>
+              <a:t>Standardized Resize</a:t>
+            </a:r>
+          </a:p>
+          <a:p>
+            <a:pPr>
+              <a:spcBef>
+                <a:spcPts val="300"/>
+              </a:spcBef>
+              <a:defRPr sz="1100">
+                <a:solidFill>
+                  <a:srgbClr val="475569"/>
+                </a:solidFill>
+              </a:defRPr>
+            </a:pPr>
+            <a:r>
+              <a:t>All images standardized and bilinearly interpolated to 224 × 224 × 3.</a:t>
+            </a:r>
+          </a:p>
+        </p:txBody>
+      </p:sp>
+      <p:sp>
+        <p:nvSpPr>
+          <p:cNvPr id="9" name="Rounded Rectangle 8"/>
           <p:cNvSpPr/>
           <p:nvPr/>
         </p:nvSpPr>
         <p:spPr>
           <a:xfrm>
-            <a:off x="4389120" y="1280160"/>
-            <a:ext cx="3410712" cy="2286000"/>
+            <a:off x="4425696" y="1280160"/>
+            <a:ext cx="3337560" cy="4937760"/>
           </a:xfrm>
           <a:prstGeom prst="roundRect">
             <a:avLst/>
@@ -7751,7 +7838,7 @@
           </a:solidFill>
           <a:ln w="12700">
             <a:solidFill>
-              <a:srgbClr val="E2E8F0"/>
+              <a:srgbClr val="E9D5FF"/>
             </a:solidFill>
           </a:ln>
         </p:spPr>
@@ -7779,14 +7866,49 @@
       </p:sp>
       <p:sp>
         <p:nvSpPr>
-          <p:cNvPr id="9" name="TextBox 8"/>
+          <p:cNvPr id="10" name="TextBox 9"/>
           <p:cNvSpPr txBox="1"/>
           <p:nvPr/>
         </p:nvSpPr>
         <p:spPr>
           <a:xfrm>
-            <a:off x="4526280" y="1417319"/>
-            <a:ext cx="3136392" cy="2011680"/>
+            <a:off x="4608576" y="1371600"/>
+            <a:ext cx="2971800" cy="457200"/>
+          </a:xfrm>
+          <a:prstGeom prst="rect">
+            <a:avLst/>
+          </a:prstGeom>
+          <a:noFill/>
+        </p:spPr>
+        <p:txBody>
+          <a:bodyPr wrap="none">
+            <a:spAutoFit/>
+          </a:bodyPr>
+          <a:lstStyle/>
+          <a:p>
+            <a:pPr>
+              <a:defRPr sz="1700" b="1">
+                <a:solidFill>
+                  <a:srgbClr val="7E22CE"/>
+                </a:solidFill>
+              </a:defRPr>
+            </a:pPr>
+            <a:r>
+              <a:t>❷  Loss Function</a:t>
+            </a:r>
+          </a:p>
+        </p:txBody>
+      </p:sp>
+      <p:sp>
+        <p:nvSpPr>
+          <p:cNvPr id="11" name="TextBox 10"/>
+          <p:cNvSpPr txBox="1"/>
+          <p:nvPr/>
+        </p:nvSpPr>
+        <p:spPr>
+          <a:xfrm>
+            <a:off x="4608576" y="1920240"/>
+            <a:ext cx="2971800" cy="4114800"/>
           </a:xfrm>
           <a:prstGeom prst="rect">
             <a:avLst/>
@@ -7800,52 +7922,103 @@
           <a:lstStyle/>
           <a:p>
             <a:pPr>
+              <a:defRPr sz="1150">
+                <a:solidFill>
+                  <a:srgbClr val="0F172A"/>
+                </a:solidFill>
+              </a:defRPr>
+            </a:pPr>
+            <a:r>
+              <a:t>We use Class-Weighted Focal Loss to combat severe class imbalance:</a:t>
+            </a:r>
+          </a:p>
+          <a:p>
+            <a:pPr>
+              <a:spcBef>
+                <a:spcPts val="1000"/>
+              </a:spcBef>
               <a:defRPr sz="1200" b="1">
                 <a:solidFill>
-                  <a:srgbClr val="0D9488"/>
-                </a:solidFill>
-              </a:defRPr>
-            </a:pPr>
-            <a:r>
-              <a:t>2. Class-Weighted Focal Loss</a:t>
+                  <a:srgbClr val="7E22CE"/>
+                </a:solidFill>
+              </a:defRPr>
+            </a:pPr>
+            <a:r>
+              <a:t>ℒ_Focal = - ∑_c α_c y_c (1 - p_c)^γ log(p_c)</a:t>
             </a:r>
           </a:p>
           <a:p>
             <a:pPr>
               <a:spcBef>
-                <a:spcPts val="600"/>
+                <a:spcPts val="1400"/>
               </a:spcBef>
-              <a:defRPr sz="1000">
-                <a:solidFill>
-                  <a:srgbClr val="0F172A"/>
-                </a:solidFill>
-              </a:defRPr>
-            </a:pPr>
-            <a:r>
-              <a:t>L_Focal = -sum y_c * alpha_c * (1 - p_c)^gamma * log(p_c)</a:t>
-            </a:r>
-            <a:br/>
-            <a:br/>
-            <a:r>
-              <a:t>• gamma = 2.0 suppresses easy majority-class gradients (Grade 0)</a:t>
-            </a:r>
-            <a:br/>
-            <a:r>
-              <a:t>• alpha_c = N / (C * N_c) enforces 9.3x higher penalty on rare Grade 3 lesions.</a:t>
-            </a:r>
-          </a:p>
-        </p:txBody>
-      </p:sp>
-      <p:sp>
-        <p:nvSpPr>
-          <p:cNvPr id="10" name="Rounded Rectangle 9"/>
+              <a:defRPr sz="1300" b="1">
+                <a:solidFill>
+                  <a:srgbClr val="7E22CE"/>
+                </a:solidFill>
+              </a:defRPr>
+            </a:pPr>
+            <a:r>
+              <a:t>γ  Gamma (γ = 2.0)</a:t>
+            </a:r>
+          </a:p>
+          <a:p>
+            <a:pPr>
+              <a:spcBef>
+                <a:spcPts val="300"/>
+              </a:spcBef>
+              <a:defRPr sz="1100">
+                <a:solidFill>
+                  <a:srgbClr val="475569"/>
+                </a:solidFill>
+              </a:defRPr>
+            </a:pPr>
+            <a:r>
+              <a:t>Suppresses gradient contributions from easy, dominant majority classes (Grade 0).</a:t>
+            </a:r>
+          </a:p>
+          <a:p>
+            <a:pPr>
+              <a:spcBef>
+                <a:spcPts val="1400"/>
+              </a:spcBef>
+              <a:defRPr sz="1300" b="1">
+                <a:solidFill>
+                  <a:srgbClr val="7E22CE"/>
+                </a:solidFill>
+              </a:defRPr>
+            </a:pPr>
+            <a:r>
+              <a:t>α  Alpha (α_c)</a:t>
+            </a:r>
+          </a:p>
+          <a:p>
+            <a:pPr>
+              <a:spcBef>
+                <a:spcPts val="300"/>
+              </a:spcBef>
+              <a:defRPr sz="1100">
+                <a:solidFill>
+                  <a:srgbClr val="475569"/>
+                </a:solidFill>
+              </a:defRPr>
+            </a:pPr>
+            <a:r>
+              <a:t>Enforces a 9.3× higher gradient penalty on rare Grade 3 lesions (α_3 = 3.81 vs α_0 = 0.41).</a:t>
+            </a:r>
+          </a:p>
+        </p:txBody>
+      </p:sp>
+      <p:sp>
+        <p:nvSpPr>
+          <p:cNvPr id="12" name="Rounded Rectangle 11"/>
           <p:cNvSpPr/>
           <p:nvPr/>
         </p:nvSpPr>
         <p:spPr>
           <a:xfrm>
-            <a:off x="8046720" y="1280160"/>
-            <a:ext cx="3410712" cy="2286000"/>
+            <a:off x="8119872" y="1280160"/>
+            <a:ext cx="3337560" cy="4937760"/>
           </a:xfrm>
           <a:prstGeom prst="roundRect">
             <a:avLst/>
@@ -7855,7 +8028,7 @@
           </a:solidFill>
           <a:ln w="12700">
             <a:solidFill>
-              <a:srgbClr val="E2E8F0"/>
+              <a:srgbClr val="CCFBF1"/>
             </a:solidFill>
           </a:ln>
         </p:spPr>
@@ -7883,14 +8056,49 @@
       </p:sp>
       <p:sp>
         <p:nvSpPr>
-          <p:cNvPr id="11" name="TextBox 10"/>
+          <p:cNvPr id="13" name="TextBox 12"/>
           <p:cNvSpPr txBox="1"/>
           <p:nvPr/>
         </p:nvSpPr>
         <p:spPr>
           <a:xfrm>
-            <a:off x="8183880" y="1417319"/>
-            <a:ext cx="3136392" cy="2011680"/>
+            <a:off x="8302752" y="1371600"/>
+            <a:ext cx="2971800" cy="457200"/>
+          </a:xfrm>
+          <a:prstGeom prst="rect">
+            <a:avLst/>
+          </a:prstGeom>
+          <a:noFill/>
+        </p:spPr>
+        <p:txBody>
+          <a:bodyPr wrap="none">
+            <a:spAutoFit/>
+          </a:bodyPr>
+          <a:lstStyle/>
+          <a:p>
+            <a:pPr>
+              <a:defRPr sz="1700" b="1">
+                <a:solidFill>
+                  <a:srgbClr val="0D9488"/>
+                </a:solidFill>
+              </a:defRPr>
+            </a:pPr>
+            <a:r>
+              <a:t>❸  Quantum Layer</a:t>
+            </a:r>
+          </a:p>
+        </p:txBody>
+      </p:sp>
+      <p:sp>
+        <p:nvSpPr>
+          <p:cNvPr id="14" name="TextBox 13"/>
+          <p:cNvSpPr txBox="1"/>
+          <p:nvPr/>
+        </p:nvSpPr>
+        <p:spPr>
+          <a:xfrm>
+            <a:off x="8302752" y="1920240"/>
+            <a:ext cx="2971800" cy="4114800"/>
           </a:xfrm>
           <a:prstGeom prst="rect">
             <a:avLst/>
@@ -7904,6 +8112,44 @@
           <a:lstStyle/>
           <a:p>
             <a:pPr>
+              <a:defRPr sz="1150">
+                <a:solidFill>
+                  <a:srgbClr val="0F172A"/>
+                </a:solidFill>
+              </a:defRPr>
+            </a:pPr>
+            <a:r>
+              <a:t>A Strongly Entangling Ansatz U(θ) is trained via the Parameter-Shift Rule for exact analytical gradients:</a:t>
+            </a:r>
+          </a:p>
+          <a:p>
+            <a:pPr>
+              <a:spcBef>
+                <a:spcPts val="800"/>
+              </a:spcBef>
+              <a:defRPr sz="950" b="1">
+                <a:solidFill>
+                  <a:srgbClr val="0D9488"/>
+                </a:solidFill>
+              </a:defRPr>
+            </a:pPr>
+            <a:r>
+              <a:t>|0⟩ ── Ry(θ_0) ── ● ─────── R(α,β,γ) ── ⟨Z_0⟩</a:t>
+            </a:r>
+            <a:br/>
+            <a:r>
+              <a:t>|0⟩ ── Ry(θ_1) ── ⊕ ── ● ── R(α,β,γ) ── ⟨Z_1⟩</a:t>
+            </a:r>
+            <a:br/>
+            <a:r>
+              <a:t>|0⟩ ── Ry(θ_2) ─────── ⊕ ── R(α,β,γ) ── ⟨Z_2⟩</a:t>
+            </a:r>
+          </a:p>
+          <a:p>
+            <a:pPr>
+              <a:spcBef>
+                <a:spcPts val="1200"/>
+              </a:spcBef>
               <a:defRPr sz="1200" b="1">
                 <a:solidFill>
                   <a:srgbClr val="1E3A8A"/>
@@ -7911,7 +8157,22 @@
               </a:defRPr>
             </a:pPr>
             <a:r>
-              <a:t>3. Quantum State Preparation</a:t>
+              <a:t>Quadratic Weighted Kappa (QWK):</a:t>
+            </a:r>
+          </a:p>
+          <a:p>
+            <a:pPr>
+              <a:spcBef>
+                <a:spcPts val="200"/>
+              </a:spcBef>
+              <a:defRPr sz="1050">
+                <a:solidFill>
+                  <a:srgbClr val="475569"/>
+                </a:solidFill>
+              </a:defRPr>
+            </a:pPr>
+            <a:r>
+              <a:t>Clinical agreement metric that penalizes distant misclassifications quadratically:</a:t>
             </a:r>
           </a:p>
           <a:p>
@@ -7919,335 +8180,18 @@
               <a:spcBef>
                 <a:spcPts val="600"/>
               </a:spcBef>
-              <a:defRPr sz="1000">
-                <a:solidFill>
-                  <a:srgbClr val="0F172A"/>
-                </a:solidFill>
-              </a:defRPr>
-            </a:pPr>
-            <a:r>
-              <a:t>|psi(z)&gt; = (X)_{i=0}^{n-1} Ry(z_i) |0&gt;</a:t>
+              <a:defRPr sz="1050" b="1">
+                <a:solidFill>
+                  <a:srgbClr val="1E3A8A"/>
+                </a:solidFill>
+              </a:defRPr>
+            </a:pPr>
+            <a:r>
+              <a:t>κ = 1 - (∑_ij w_ij O_ij) / (∑_ij w_ij E_ij)</a:t>
             </a:r>
             <a:br/>
-            <a:br/>
-            <a:r>
-              <a:t>• Continuous angles z_i in [-pi, pi] rotate qubits on Bloch sphere</a:t>
-            </a:r>
-            <a:br/>
-            <a:r>
-              <a:t>• Constant circuit depth O(1); zero multi-qubit CNOT overhead.</a:t>
-            </a:r>
-          </a:p>
-        </p:txBody>
-      </p:sp>
-      <p:sp>
-        <p:nvSpPr>
-          <p:cNvPr id="12" name="Rounded Rectangle 11"/>
-          <p:cNvSpPr/>
-          <p:nvPr/>
-        </p:nvSpPr>
-        <p:spPr>
-          <a:xfrm>
-            <a:off x="731520" y="3749039"/>
-            <a:ext cx="3410712" cy="2286000"/>
-          </a:xfrm>
-          <a:prstGeom prst="roundRect">
-            <a:avLst/>
-          </a:prstGeom>
-          <a:solidFill>
-            <a:srgbClr val="FFFFFF"/>
-          </a:solidFill>
-          <a:ln w="12700">
-            <a:solidFill>
-              <a:srgbClr val="E2E8F0"/>
-            </a:solidFill>
-          </a:ln>
-        </p:spPr>
-        <p:style>
-          <a:lnRef idx="1">
-            <a:schemeClr val="accent1"/>
-          </a:lnRef>
-          <a:fillRef idx="3">
-            <a:schemeClr val="accent1"/>
-          </a:fillRef>
-          <a:effectRef idx="2">
-            <a:schemeClr val="accent1"/>
-          </a:effectRef>
-          <a:fontRef idx="minor">
-            <a:schemeClr val="lt1"/>
-          </a:fontRef>
-        </p:style>
-        <p:txBody>
-          <a:bodyPr rtlCol="0" anchor="ctr"/>
-          <a:lstStyle/>
-          <a:p>
-            <a:pPr algn="ctr"/>
-          </a:p>
-        </p:txBody>
-      </p:sp>
-      <p:sp>
-        <p:nvSpPr>
-          <p:cNvPr id="13" name="TextBox 12"/>
-          <p:cNvSpPr txBox="1"/>
-          <p:nvPr/>
-        </p:nvSpPr>
-        <p:spPr>
-          <a:xfrm>
-            <a:off x="868680" y="3886200"/>
-            <a:ext cx="3136392" cy="2011680"/>
-          </a:xfrm>
-          <a:prstGeom prst="rect">
-            <a:avLst/>
-          </a:prstGeom>
-          <a:noFill/>
-        </p:spPr>
-        <p:txBody>
-          <a:bodyPr wrap="square">
-            <a:spAutoFit/>
-          </a:bodyPr>
-          <a:lstStyle/>
-          <a:p>
-            <a:pPr>
-              <a:defRPr sz="1200" b="1">
-                <a:solidFill>
-                  <a:srgbClr val="0D9488"/>
-                </a:solidFill>
-              </a:defRPr>
-            </a:pPr>
-            <a:r>
-              <a:t>4. Strongly Entangling Ansatz</a:t>
-            </a:r>
-          </a:p>
-          <a:p>
-            <a:pPr>
-              <a:spcBef>
-                <a:spcPts val="600"/>
-              </a:spcBef>
-              <a:defRPr sz="1000">
-                <a:solidFill>
-                  <a:srgbClr val="0F172A"/>
-                </a:solidFill>
-              </a:defRPr>
-            </a:pPr>
-            <a:r>
-              <a:t>U(theta) = Prod_{l=1}^L [ U_ent * (X) R(alpha, beta, gamma) ]</a:t>
-            </a:r>
-            <a:br/>
-            <a:br/>
-            <a:r>
-              <a:t>• 3 Euler rotation angles per qubit: Rz(gamma) Ry(beta) Rx(alpha)</a:t>
-            </a:r>
-            <a:br/>
-            <a:r>
-              <a:t>• Periodic circular CNOT ring generates multi-qubit entanglement.</a:t>
-            </a:r>
-          </a:p>
-        </p:txBody>
-      </p:sp>
-      <p:sp>
-        <p:nvSpPr>
-          <p:cNvPr id="14" name="Rounded Rectangle 13"/>
-          <p:cNvSpPr/>
-          <p:nvPr/>
-        </p:nvSpPr>
-        <p:spPr>
-          <a:xfrm>
-            <a:off x="4389120" y="3749039"/>
-            <a:ext cx="3410712" cy="2286000"/>
-          </a:xfrm>
-          <a:prstGeom prst="roundRect">
-            <a:avLst/>
-          </a:prstGeom>
-          <a:solidFill>
-            <a:srgbClr val="FFFFFF"/>
-          </a:solidFill>
-          <a:ln w="12700">
-            <a:solidFill>
-              <a:srgbClr val="E2E8F0"/>
-            </a:solidFill>
-          </a:ln>
-        </p:spPr>
-        <p:style>
-          <a:lnRef idx="1">
-            <a:schemeClr val="accent1"/>
-          </a:lnRef>
-          <a:fillRef idx="3">
-            <a:schemeClr val="accent1"/>
-          </a:fillRef>
-          <a:effectRef idx="2">
-            <a:schemeClr val="accent1"/>
-          </a:effectRef>
-          <a:fontRef idx="minor">
-            <a:schemeClr val="lt1"/>
-          </a:fontRef>
-        </p:style>
-        <p:txBody>
-          <a:bodyPr rtlCol="0" anchor="ctr"/>
-          <a:lstStyle/>
-          <a:p>
-            <a:pPr algn="ctr"/>
-          </a:p>
-        </p:txBody>
-      </p:sp>
-      <p:sp>
-        <p:nvSpPr>
-          <p:cNvPr id="15" name="TextBox 14"/>
-          <p:cNvSpPr txBox="1"/>
-          <p:nvPr/>
-        </p:nvSpPr>
-        <p:spPr>
-          <a:xfrm>
-            <a:off x="4526280" y="3886200"/>
-            <a:ext cx="3136392" cy="2011680"/>
-          </a:xfrm>
-          <a:prstGeom prst="rect">
-            <a:avLst/>
-          </a:prstGeom>
-          <a:noFill/>
-        </p:spPr>
-        <p:txBody>
-          <a:bodyPr wrap="square">
-            <a:spAutoFit/>
-          </a:bodyPr>
-          <a:lstStyle/>
-          <a:p>
-            <a:pPr>
-              <a:defRPr sz="1200" b="1">
-                <a:solidFill>
-                  <a:srgbClr val="1E3A8A"/>
-                </a:solidFill>
-              </a:defRPr>
-            </a:pPr>
-            <a:r>
-              <a:t>5. Parameter-Shift Rule</a:t>
-            </a:r>
-          </a:p>
-          <a:p>
-            <a:pPr>
-              <a:spcBef>
-                <a:spcPts val="600"/>
-              </a:spcBef>
-              <a:defRPr sz="1000">
-                <a:solidFill>
-                  <a:srgbClr val="0F172A"/>
-                </a:solidFill>
-              </a:defRPr>
-            </a:pPr>
-            <a:r>
-              <a:t>d&lt;Z_i&gt;/dtheta_j = (&lt;Z_i&gt;(theta_j + pi/2) - &lt;Z_i&gt;(theta_j - pi/2)) / 2</a:t>
-            </a:r>
-            <a:br/>
-            <a:br/>
-            <a:r>
-              <a:t>• Evaluates exact analytical gradients without intermediate state readout</a:t>
-            </a:r>
-            <a:br/>
-            <a:r>
-              <a:t>• Enables hardware-native backpropagation on physical QPUs.</a:t>
-            </a:r>
-          </a:p>
-        </p:txBody>
-      </p:sp>
-      <p:sp>
-        <p:nvSpPr>
-          <p:cNvPr id="16" name="Rounded Rectangle 15"/>
-          <p:cNvSpPr/>
-          <p:nvPr/>
-        </p:nvSpPr>
-        <p:spPr>
-          <a:xfrm>
-            <a:off x="8046720" y="3749039"/>
-            <a:ext cx="3410712" cy="2286000"/>
-          </a:xfrm>
-          <a:prstGeom prst="roundRect">
-            <a:avLst/>
-          </a:prstGeom>
-          <a:solidFill>
-            <a:srgbClr val="FFFFFF"/>
-          </a:solidFill>
-          <a:ln w="12700">
-            <a:solidFill>
-              <a:srgbClr val="E2E8F0"/>
-            </a:solidFill>
-          </a:ln>
-        </p:spPr>
-        <p:style>
-          <a:lnRef idx="1">
-            <a:schemeClr val="accent1"/>
-          </a:lnRef>
-          <a:fillRef idx="3">
-            <a:schemeClr val="accent1"/>
-          </a:fillRef>
-          <a:effectRef idx="2">
-            <a:schemeClr val="accent1"/>
-          </a:effectRef>
-          <a:fontRef idx="minor">
-            <a:schemeClr val="lt1"/>
-          </a:fontRef>
-        </p:style>
-        <p:txBody>
-          <a:bodyPr rtlCol="0" anchor="ctr"/>
-          <a:lstStyle/>
-          <a:p>
-            <a:pPr algn="ctr"/>
-          </a:p>
-        </p:txBody>
-      </p:sp>
-      <p:sp>
-        <p:nvSpPr>
-          <p:cNvPr id="17" name="TextBox 16"/>
-          <p:cNvSpPr txBox="1"/>
-          <p:nvPr/>
-        </p:nvSpPr>
-        <p:spPr>
-          <a:xfrm>
-            <a:off x="8183880" y="3886200"/>
-            <a:ext cx="3136392" cy="2011680"/>
-          </a:xfrm>
-          <a:prstGeom prst="rect">
-            <a:avLst/>
-          </a:prstGeom>
-          <a:noFill/>
-        </p:spPr>
-        <p:txBody>
-          <a:bodyPr wrap="square">
-            <a:spAutoFit/>
-          </a:bodyPr>
-          <a:lstStyle/>
-          <a:p>
-            <a:pPr>
-              <a:defRPr sz="1200" b="1">
-                <a:solidFill>
-                  <a:srgbClr val="0D9488"/>
-                </a:solidFill>
-              </a:defRPr>
-            </a:pPr>
-            <a:r>
-              <a:t>6. Quadratic Weighted Kappa</a:t>
-            </a:r>
-          </a:p>
-          <a:p>
-            <a:pPr>
-              <a:spcBef>
-                <a:spcPts val="600"/>
-              </a:spcBef>
-              <a:defRPr sz="1000">
-                <a:solidFill>
-                  <a:srgbClr val="0F172A"/>
-                </a:solidFill>
-              </a:defRPr>
-            </a:pPr>
-            <a:r>
-              <a:t>kappa = 1 - (sum w_ij O_ij) / (sum w_ij E_ij)</a:t>
-            </a:r>
-            <a:br/>
-            <a:br/>
-            <a:r>
-              <a:t>w_ij = (i - j)^2 / (C - 1)^2 = (i - j)^2 / 16</a:t>
-            </a:r>
-            <a:br/>
-            <a:r>
-              <a:t>• Penalizes severe clinical misclassifications quadratically (w_0,4 = 1.0 vs w_0,1 = 0.0625).</a:t>
+            <a:r>
+              <a:t>w_ij = (i - j)² / 16  (w_0,4 = 1.0 vs w_0,1 = 0.0625)</a:t>
             </a:r>
           </a:p>
         </p:txBody>

</xml_diff>